<commit_message>
docs(slides): correct test count to 216
事実誤記の訂正。現在の実測は 216 passed で、README.md と Google Drive 提出用
スライドは既に 216 に修正済みだが、GitHub 収録版の 11 枚だけ古い 202 が
残っていた。提出物間の不整合を解消する。

変更（テキストのみ、2 run）:
- slide 7  TextBox 13 : "202 tests" -> "216 tests"
- slide 11 Backup B3  : "テスト 202 件" -> "テスト 216 件"

当初の指示は Backup B3 の 1 箇所だったが、11 枚版には slide 7 にも
"202 tests" があり（Drive 版は slide 7 ごと削除済みのため B3 のみだった）、
「202 を 0 件にする」という監査条件と両立しないため確認のうえ 2 箇所とした。

監査:
- 11 枚のまま。run 総数 159 -> 159、キー集合同一
- 変更された run は slide 7 / slide 11 の 2 件のみ。他の 9 枚は
  全 137 run が完全同一
- 2 run ともテキスト差は 202 -> 216 のみで、font / size / bold /
  italic / underline / color は不変
- 全 shape の位置・サイズが不変。202 と 216 は同じ 3 文字なので行長も不変
- はみ出し 0 件 / 重なり 0 件
- Google Drive 提出用 slides/0148_IgariTakayuki_CosplayReserve_Slides.pptx は
  無変更のまま未追跡（sha256 2671135f533a4fa9a0d627a1bae3887d）
- outputs/ / README.md / RESULTS.md / make_pptx.py は無変更
- API / LLM call 0 件、費用 $0

Co-Authored-By: Claude Opus 5 <noreply@anthropic.com>
</commit_message>
<xml_diff>
--- a/slides/cosplay_reserve_final.pptx
+++ b/slides/cosplay_reserve_final.pptx
@@ -5543,7 +5543,7 @@
                 </a:solidFill>
                 <a:latin typeface="Meiryo"/>
               </a:rPr>
-              <a:t>API 不使用で再現できる範囲: M1 全体 ／ 感度分析 replay ／ 主結果の再判定 ／ テスト 202 件。</a:t>
+              <a:t>API 不使用で再現できる範囲: M1 全体 ／ 感度分析 replay ／ 主結果の再判定 ／ テスト 216 件。</a:t>
             </a:r>
           </a:p>
           <a:p>
@@ -9583,7 +9583,7 @@
                 </a:solidFill>
                 <a:latin typeface="Consolas"/>
               </a:rPr>
-              <a:t>202 tests  /  preregistered adjudication  /  API-free replay</a:t>
+              <a:t>216 tests  /  preregistered adjudication  /  API-free replay</a:t>
             </a:r>
           </a:p>
         </p:txBody>

</xml_diff>